<commit_message>
Fix KPI figures: correct AOV (), Quantity (5,615), Revenue (,771), Profit (,963)
</commit_message>
<xml_diff>
--- a/Ecommerce Sales Dashboard Analysis.pptx
+++ b/Ecommerce Sales Dashboard Analysis.pptx
@@ -4146,6 +4146,10 @@
             <a:tailEnd type="none"/>
           </a:ln>
         </p:spPr>
+        <p:txBody>
+          <a:bodyPr/>
+          <a:p/>
+        </p:txBody>
       </p:sp>
       <p:sp>
         <p:nvSpPr>
@@ -4171,6 +4175,10 @@
             <a:tailEnd type="none"/>
           </a:ln>
         </p:spPr>
+        <p:txBody>
+          <a:bodyPr/>
+          <a:p/>
+        </p:txBody>
       </p:sp>
       <p:sp>
         <p:nvSpPr>
@@ -4392,6 +4400,10 @@
           </a:solidFill>
           <a:ln/>
         </p:spPr>
+        <p:txBody>
+          <a:bodyPr/>
+          <a:p/>
+        </p:txBody>
       </p:sp>
       <p:sp>
         <p:nvSpPr>
@@ -4493,6 +4505,10 @@
           </a:solidFill>
           <a:ln/>
         </p:spPr>
+        <p:txBody>
+          <a:bodyPr/>
+          <a:p/>
+        </p:txBody>
       </p:sp>
     </p:spTree>
   </p:cSld>
@@ -4547,6 +4563,10 @@
             <a:tailEnd type="none"/>
           </a:ln>
         </p:spPr>
+        <p:txBody>
+          <a:bodyPr/>
+          <a:p/>
+        </p:txBody>
       </p:sp>
       <p:sp>
         <p:nvSpPr>
@@ -4588,6 +4608,10 @@
           </a:solidFill>
           <a:ln/>
         </p:spPr>
+        <p:txBody>
+          <a:bodyPr/>
+          <a:p/>
+        </p:txBody>
       </p:sp>
       <p:sp>
         <p:nvSpPr>
@@ -4757,6 +4781,10 @@
           </a:solidFill>
           <a:ln/>
         </p:spPr>
+        <p:txBody>
+          <a:bodyPr/>
+          <a:p/>
+        </p:txBody>
       </p:sp>
       <p:sp>
         <p:nvSpPr>
@@ -5070,6 +5098,10 @@
             <a:prstDash val="solid"/>
           </a:ln>
         </p:spPr>
+        <p:txBody>
+          <a:bodyPr/>
+          <a:p/>
+        </p:txBody>
       </p:sp>
       <p:sp>
         <p:nvSpPr>
@@ -5152,6 +5184,10 @@
             <a:tailEnd type="none"/>
           </a:ln>
         </p:spPr>
+        <p:txBody>
+          <a:bodyPr/>
+          <a:p/>
+        </p:txBody>
       </p:sp>
     </p:spTree>
   </p:cSld>
@@ -5236,6 +5272,10 @@
             <a:tailEnd type="none"/>
           </a:ln>
         </p:spPr>
+        <p:txBody>
+          <a:bodyPr/>
+          <a:p/>
+        </p:txBody>
       </p:sp>
       <p:sp>
         <p:nvSpPr>
@@ -5261,6 +5301,10 @@
             <a:tailEnd type="none"/>
           </a:ln>
         </p:spPr>
+        <p:txBody>
+          <a:bodyPr/>
+          <a:p/>
+        </p:txBody>
       </p:sp>
       <p:sp>
         <p:nvSpPr>
@@ -5286,6 +5330,10 @@
             <a:tailEnd type="none"/>
           </a:ln>
         </p:spPr>
+        <p:txBody>
+          <a:bodyPr/>
+          <a:p/>
+        </p:txBody>
       </p:sp>
       <p:sp>
         <p:nvSpPr>
@@ -5466,6 +5514,10 @@
           </a:solidFill>
           <a:ln/>
         </p:spPr>
+        <p:txBody>
+          <a:bodyPr/>
+          <a:p/>
+        </p:txBody>
       </p:sp>
       <p:sp>
         <p:nvSpPr>
@@ -5580,6 +5632,10 @@
             <a:tailEnd type="none"/>
           </a:ln>
         </p:spPr>
+        <p:txBody>
+          <a:bodyPr/>
+          <a:p/>
+        </p:txBody>
       </p:sp>
       <p:sp>
         <p:nvSpPr>
@@ -5621,6 +5677,10 @@
           </a:solidFill>
           <a:ln/>
         </p:spPr>
+        <p:txBody>
+          <a:bodyPr/>
+          <a:p/>
+        </p:txBody>
       </p:sp>
       <p:sp>
         <p:nvSpPr>
@@ -5758,6 +5818,10 @@
           </a:solidFill>
           <a:ln/>
         </p:spPr>
+        <p:txBody>
+          <a:bodyPr/>
+          <a:p/>
+        </p:txBody>
       </p:sp>
       <p:sp>
         <p:nvSpPr>
@@ -5995,6 +6059,10 @@
           </a:solidFill>
           <a:ln/>
         </p:spPr>
+        <p:txBody>
+          <a:bodyPr/>
+          <a:p/>
+        </p:txBody>
       </p:sp>
       <p:sp>
         <p:nvSpPr>
@@ -6088,6 +6156,10 @@
           </a:solidFill>
           <a:ln/>
         </p:spPr>
+        <p:txBody>
+          <a:bodyPr/>
+          <a:p/>
+        </p:txBody>
       </p:sp>
       <p:sp>
         <p:nvSpPr>
@@ -6325,6 +6397,10 @@
           </a:solidFill>
           <a:ln/>
         </p:spPr>
+        <p:txBody>
+          <a:bodyPr/>
+          <a:p/>
+        </p:txBody>
       </p:sp>
       <p:sp>
         <p:nvSpPr>
@@ -6418,6 +6494,10 @@
           </a:solidFill>
           <a:ln/>
         </p:spPr>
+        <p:txBody>
+          <a:bodyPr/>
+          <a:p/>
+        </p:txBody>
       </p:sp>
       <p:sp>
         <p:nvSpPr>
@@ -6655,6 +6735,10 @@
           </a:solidFill>
           <a:ln/>
         </p:spPr>
+        <p:txBody>
+          <a:bodyPr/>
+          <a:p/>
+        </p:txBody>
       </p:sp>
       <p:sp>
         <p:nvSpPr>
@@ -6748,6 +6832,10 @@
           </a:solidFill>
           <a:ln/>
         </p:spPr>
+        <p:txBody>
+          <a:bodyPr/>
+          <a:p/>
+        </p:txBody>
       </p:sp>
       <p:sp>
         <p:nvSpPr>
@@ -7270,6 +7358,10 @@
             <a:tailEnd type="none"/>
           </a:ln>
         </p:spPr>
+        <p:txBody>
+          <a:bodyPr/>
+          <a:p/>
+        </p:txBody>
       </p:sp>
     </p:spTree>
   </p:cSld>
@@ -7324,6 +7416,10 @@
             <a:tailEnd type="none"/>
           </a:ln>
         </p:spPr>
+        <p:txBody>
+          <a:bodyPr/>
+          <a:p/>
+        </p:txBody>
       </p:sp>
       <p:sp>
         <p:nvSpPr>
@@ -7365,6 +7461,10 @@
           </a:solidFill>
           <a:ln/>
         </p:spPr>
+        <p:txBody>
+          <a:bodyPr/>
+          <a:p/>
+        </p:txBody>
       </p:sp>
       <p:sp>
         <p:nvSpPr>
@@ -8880,6 +8980,10 @@
           </a:solidFill>
           <a:ln/>
         </p:spPr>
+        <p:txBody>
+          <a:bodyPr/>
+          <a:p/>
+        </p:txBody>
       </p:sp>
       <p:sp>
         <p:nvSpPr>
@@ -9099,6 +9203,10 @@
             <a:prstDash val="solid"/>
           </a:ln>
         </p:spPr>
+        <p:txBody>
+          <a:bodyPr/>
+          <a:p/>
+        </p:txBody>
       </p:sp>
       <p:sp>
         <p:nvSpPr>
@@ -9181,6 +9289,10 @@
             <a:tailEnd type="none"/>
           </a:ln>
         </p:spPr>
+        <p:txBody>
+          <a:bodyPr/>
+          <a:p/>
+        </p:txBody>
       </p:sp>
     </p:spTree>
   </p:cSld>
@@ -9265,6 +9377,10 @@
             <a:tailEnd type="none"/>
           </a:ln>
         </p:spPr>
+        <p:txBody>
+          <a:bodyPr/>
+          <a:p/>
+        </p:txBody>
       </p:sp>
       <p:sp>
         <p:nvSpPr>
@@ -9290,6 +9406,10 @@
             <a:tailEnd type="none"/>
           </a:ln>
         </p:spPr>
+        <p:txBody>
+          <a:bodyPr/>
+          <a:p/>
+        </p:txBody>
       </p:sp>
       <p:sp>
         <p:nvSpPr>
@@ -9315,6 +9435,10 @@
             <a:tailEnd type="none"/>
           </a:ln>
         </p:spPr>
+        <p:txBody>
+          <a:bodyPr/>
+          <a:p/>
+        </p:txBody>
       </p:sp>
       <p:sp>
         <p:nvSpPr>
@@ -9495,6 +9619,10 @@
           </a:solidFill>
           <a:ln/>
         </p:spPr>
+        <p:txBody>
+          <a:bodyPr/>
+          <a:p/>
+        </p:txBody>
       </p:sp>
       <p:sp>
         <p:nvSpPr>
@@ -9609,6 +9737,10 @@
             <a:tailEnd type="none"/>
           </a:ln>
         </p:spPr>
+        <p:txBody>
+          <a:bodyPr/>
+          <a:p/>
+        </p:txBody>
       </p:sp>
       <p:sp>
         <p:nvSpPr>
@@ -9650,6 +9782,10 @@
           </a:solidFill>
           <a:ln/>
         </p:spPr>
+        <p:txBody>
+          <a:bodyPr/>
+          <a:p/>
+        </p:txBody>
       </p:sp>
       <p:sp>
         <p:nvSpPr>
@@ -9828,6 +9964,10 @@
           </a:solidFill>
           <a:ln/>
         </p:spPr>
+        <p:txBody>
+          <a:bodyPr/>
+          <a:p/>
+        </p:txBody>
       </p:sp>
       <p:sp>
         <p:nvSpPr>
@@ -10012,6 +10152,10 @@
           </a:solidFill>
           <a:ln/>
         </p:spPr>
+        <p:txBody>
+          <a:bodyPr/>
+          <a:p/>
+        </p:txBody>
       </p:sp>
       <p:sp>
         <p:nvSpPr>
@@ -10196,6 +10340,10 @@
           </a:solidFill>
           <a:ln/>
         </p:spPr>
+        <p:txBody>
+          <a:bodyPr/>
+          <a:p/>
+        </p:txBody>
       </p:sp>
       <p:sp>
         <p:nvSpPr>
@@ -10380,6 +10528,10 @@
           </a:solidFill>
           <a:ln/>
         </p:spPr>
+        <p:txBody>
+          <a:bodyPr/>
+          <a:p/>
+        </p:txBody>
       </p:sp>
       <p:sp>
         <p:nvSpPr>
@@ -10610,6 +10762,10 @@
             <a:prstDash val="solid"/>
           </a:ln>
         </p:spPr>
+        <p:txBody>
+          <a:bodyPr/>
+          <a:p/>
+        </p:txBody>
       </p:sp>
       <p:sp>
         <p:nvSpPr>
@@ -10670,7 +10826,7 @@
                 <a:ea typeface="Quattrocento Sans" pitchFamily="34" charset="-122"/>
                 <a:cs typeface="Quattrocento Sans" pitchFamily="34" charset="-120"/>
               </a:rPr>
-              <a:t>438,000</a:t>
+              <a:t>$437,771</a:t>
             </a:r>
             <a:pPr algn="l">
               <a:lnSpc>
@@ -10932,6 +11088,10 @@
             <a:prstDash val="solid"/>
           </a:ln>
         </p:spPr>
+        <p:txBody>
+          <a:bodyPr/>
+          <a:p/>
+        </p:txBody>
       </p:sp>
       <p:sp>
         <p:nvSpPr>
@@ -11325,6 +11485,10 @@
           </a:solidFill>
           <a:ln/>
         </p:spPr>
+        <p:txBody>
+          <a:bodyPr/>
+          <a:p/>
+        </p:txBody>
       </p:sp>
       <p:sp>
         <p:nvSpPr>
@@ -11405,6 +11569,10 @@
           </a:solidFill>
           <a:ln/>
         </p:spPr>
+        <p:txBody>
+          <a:bodyPr/>
+          <a:p/>
+        </p:txBody>
       </p:sp>
       <p:sp>
         <p:nvSpPr>
@@ -11485,6 +11653,10 @@
           </a:solidFill>
           <a:ln/>
         </p:spPr>
+        <p:txBody>
+          <a:bodyPr/>
+          <a:p/>
+        </p:txBody>
       </p:sp>
       <p:sp>
         <p:nvSpPr>
@@ -11565,6 +11737,10 @@
           </a:solidFill>
           <a:ln/>
         </p:spPr>
+        <p:txBody>
+          <a:bodyPr/>
+          <a:p/>
+        </p:txBody>
       </p:sp>
       <p:sp>
         <p:nvSpPr>
@@ -11645,6 +11821,10 @@
           </a:solidFill>
           <a:ln/>
         </p:spPr>
+        <p:txBody>
+          <a:bodyPr/>
+          <a:p/>
+        </p:txBody>
       </p:sp>
       <p:sp>
         <p:nvSpPr>
@@ -11730,6 +11910,10 @@
             <a:tailEnd type="none"/>
           </a:ln>
         </p:spPr>
+        <p:txBody>
+          <a:bodyPr/>
+          <a:p/>
+        </p:txBody>
       </p:sp>
     </p:spTree>
   </p:cSld>
@@ -11956,6 +12140,10 @@
             <a:tailEnd type="none"/>
           </a:ln>
         </p:spPr>
+        <p:txBody>
+          <a:bodyPr/>
+          <a:p/>
+        </p:txBody>
       </p:sp>
       <p:sp>
         <p:nvSpPr>
@@ -11981,6 +12169,10 @@
             <a:tailEnd type="none"/>
           </a:ln>
         </p:spPr>
+        <p:txBody>
+          <a:bodyPr/>
+          <a:p/>
+        </p:txBody>
       </p:sp>
       <p:sp>
         <p:nvSpPr>
@@ -12082,6 +12274,10 @@
           </a:solidFill>
           <a:ln/>
         </p:spPr>
+        <p:txBody>
+          <a:bodyPr/>
+          <a:p/>
+        </p:txBody>
       </p:sp>
     </p:spTree>
   </p:cSld>
@@ -12136,6 +12332,10 @@
             <a:tailEnd type="none"/>
           </a:ln>
         </p:spPr>
+        <p:txBody>
+          <a:bodyPr/>
+          <a:p/>
+        </p:txBody>
       </p:sp>
       <p:sp>
         <p:nvSpPr>
@@ -12177,6 +12377,10 @@
           </a:solidFill>
           <a:ln/>
         </p:spPr>
+        <p:txBody>
+          <a:bodyPr/>
+          <a:p/>
+        </p:txBody>
       </p:sp>
       <p:sp>
         <p:nvSpPr>
@@ -12322,6 +12526,10 @@
             <a:tailEnd type="none"/>
           </a:ln>
         </p:spPr>
+        <p:txBody>
+          <a:bodyPr/>
+          <a:p/>
+        </p:txBody>
       </p:sp>
       <p:pic>
         <p:nvPicPr>
@@ -13096,6 +13304,10 @@
             <a:tailEnd type="none"/>
           </a:ln>
         </p:spPr>
+        <p:txBody>
+          <a:bodyPr/>
+          <a:p/>
+        </p:txBody>
       </p:sp>
       <p:sp>
         <p:nvSpPr>
@@ -13121,6 +13333,10 @@
             <a:tailEnd type="none"/>
           </a:ln>
         </p:spPr>
+        <p:txBody>
+          <a:bodyPr/>
+          <a:p/>
+        </p:txBody>
       </p:sp>
       <p:sp>
         <p:nvSpPr>
@@ -13146,6 +13362,10 @@
             <a:tailEnd type="none"/>
           </a:ln>
         </p:spPr>
+        <p:txBody>
+          <a:bodyPr/>
+          <a:p/>
+        </p:txBody>
       </p:sp>
       <p:sp>
         <p:nvSpPr>
@@ -13326,6 +13546,10 @@
           </a:solidFill>
           <a:ln/>
         </p:spPr>
+        <p:txBody>
+          <a:bodyPr/>
+          <a:p/>
+        </p:txBody>
       </p:sp>
       <p:sp>
         <p:nvSpPr>
@@ -13440,6 +13664,10 @@
             <a:tailEnd type="none"/>
           </a:ln>
         </p:spPr>
+        <p:txBody>
+          <a:bodyPr/>
+          <a:p/>
+        </p:txBody>
       </p:sp>
       <p:sp>
         <p:nvSpPr>
@@ -13481,6 +13709,10 @@
           </a:solidFill>
           <a:ln/>
         </p:spPr>
+        <p:txBody>
+          <a:bodyPr/>
+          <a:p/>
+        </p:txBody>
       </p:sp>
       <p:sp>
         <p:nvSpPr>
@@ -13561,6 +13793,10 @@
           </a:solidFill>
           <a:ln/>
         </p:spPr>
+        <p:txBody>
+          <a:bodyPr/>
+          <a:p/>
+        </p:txBody>
       </p:sp>
       <p:sp>
         <p:nvSpPr>
@@ -13638,6 +13874,10 @@
           </a:solidFill>
           <a:ln/>
         </p:spPr>
+        <p:txBody>
+          <a:bodyPr/>
+          <a:p/>
+        </p:txBody>
       </p:sp>
       <p:sp>
         <p:nvSpPr>
@@ -13674,7 +13914,7 @@
                 <a:ea typeface="Coda" pitchFamily="34" charset="-122"/>
                 <a:cs typeface="Coda" pitchFamily="34" charset="-120"/>
               </a:rPr>
-              <a:t>438K</a:t>
+              <a:t>$437,771</a:t>
             </a:r>
             <a:endParaRPr lang="en-US" sz="6400" dirty="0"/>
           </a:p>
@@ -13800,6 +14040,10 @@
           </a:solidFill>
           <a:ln/>
         </p:spPr>
+        <p:txBody>
+          <a:bodyPr/>
+          <a:p/>
+        </p:txBody>
       </p:sp>
       <p:sp>
         <p:nvSpPr>
@@ -13836,7 +14080,7 @@
                 <a:ea typeface="Coda" pitchFamily="34" charset="-122"/>
                 <a:cs typeface="Coda" pitchFamily="34" charset="-120"/>
               </a:rPr>
-              <a:t>37K</a:t>
+              <a:t>$36,963</a:t>
             </a:r>
             <a:endParaRPr lang="en-US" sz="6400" dirty="0"/>
           </a:p>
@@ -13962,6 +14206,10 @@
           </a:solidFill>
           <a:ln/>
         </p:spPr>
+        <p:txBody>
+          <a:bodyPr/>
+          <a:p/>
+        </p:txBody>
       </p:sp>
       <p:sp>
         <p:nvSpPr>
@@ -13998,7 +14246,7 @@
                 <a:ea typeface="Coda" pitchFamily="34" charset="-122"/>
                 <a:cs typeface="Coda" pitchFamily="34" charset="-120"/>
               </a:rPr>
-              <a:t>6,000</a:t>
+              <a:t>5,615</a:t>
             </a:r>
             <a:endParaRPr lang="en-US" sz="6400" dirty="0"/>
           </a:p>
@@ -14124,6 +14372,10 @@
           </a:solidFill>
           <a:ln/>
         </p:spPr>
+        <p:txBody>
+          <a:bodyPr/>
+          <a:p/>
+        </p:txBody>
       </p:sp>
       <p:sp>
         <p:nvSpPr>
@@ -14291,6 +14543,10 @@
             <a:prstDash val="solid"/>
           </a:ln>
         </p:spPr>
+        <p:txBody>
+          <a:bodyPr/>
+          <a:p/>
+        </p:txBody>
       </p:sp>
       <p:sp>
         <p:nvSpPr>
@@ -14405,6 +14661,10 @@
             <a:tailEnd type="none"/>
           </a:ln>
         </p:spPr>
+        <p:txBody>
+          <a:bodyPr/>
+          <a:p/>
+        </p:txBody>
       </p:sp>
     </p:spTree>
   </p:cSld>
@@ -14459,6 +14719,10 @@
             <a:tailEnd type="none"/>
           </a:ln>
         </p:spPr>
+        <p:txBody>
+          <a:bodyPr/>
+          <a:p/>
+        </p:txBody>
       </p:sp>
       <p:sp>
         <p:nvSpPr>
@@ -14500,6 +14764,10 @@
           </a:solidFill>
           <a:ln/>
         </p:spPr>
+        <p:txBody>
+          <a:bodyPr/>
+          <a:p/>
+        </p:txBody>
       </p:sp>
       <p:sp>
         <p:nvSpPr>
@@ -16666,6 +16934,10 @@
           </a:solidFill>
           <a:ln/>
         </p:spPr>
+        <p:txBody>
+          <a:bodyPr/>
+          <a:p/>
+        </p:txBody>
       </p:sp>
       <p:sp>
         <p:nvSpPr>
@@ -16791,7 +17063,7 @@
                 <a:ea typeface="Quattrocento Sans" pitchFamily="34" charset="-122"/>
                 <a:cs typeface="Quattrocento Sans" pitchFamily="34" charset="-120"/>
               </a:rPr>
-              <a:t>438,000</a:t>
+              <a:t>$437,771</a:t>
             </a:r>
             <a:pPr algn="l">
               <a:lnSpc>
@@ -16891,6 +17163,10 @@
             <a:tailEnd type="none"/>
           </a:ln>
         </p:spPr>
+        <p:txBody>
+          <a:bodyPr/>
+          <a:p/>
+        </p:txBody>
       </p:sp>
       <p:sp>
         <p:nvSpPr>
@@ -16927,7 +17203,7 @@
                 <a:ea typeface="Quattrocento Sans" pitchFamily="34" charset="-122"/>
                 <a:cs typeface="Quattrocento Sans" pitchFamily="34" charset="-120"/>
               </a:rPr>
-              <a:t>438,000</a:t>
+              <a:t>$437,771</a:t>
             </a:r>
             <a:pPr algn="l">
               <a:lnSpc>
@@ -16962,7 +17238,7 @@
                 <a:ea typeface="Quattrocento Sans" pitchFamily="34" charset="-122"/>
                 <a:cs typeface="Quattrocento Sans" pitchFamily="34" charset="-120"/>
               </a:rPr>
-              <a:t>37,000</a:t>
+              <a:t>$36,963</a:t>
             </a:r>
             <a:pPr algn="l">
               <a:lnSpc>
@@ -17078,6 +17354,10 @@
             <a:tailEnd type="none"/>
           </a:ln>
         </p:spPr>
+        <p:txBody>
+          <a:bodyPr/>
+          <a:p/>
+        </p:txBody>
       </p:sp>
     </p:spTree>
   </p:cSld>
@@ -17162,6 +17442,10 @@
             <a:tailEnd type="none"/>
           </a:ln>
         </p:spPr>
+        <p:txBody>
+          <a:bodyPr/>
+          <a:p/>
+        </p:txBody>
       </p:sp>
       <p:sp>
         <p:nvSpPr>
@@ -17187,6 +17471,10 @@
             <a:tailEnd type="none"/>
           </a:ln>
         </p:spPr>
+        <p:txBody>
+          <a:bodyPr/>
+          <a:p/>
+        </p:txBody>
       </p:sp>
       <p:sp>
         <p:nvSpPr>
@@ -17212,6 +17500,10 @@
             <a:tailEnd type="none"/>
           </a:ln>
         </p:spPr>
+        <p:txBody>
+          <a:bodyPr/>
+          <a:p/>
+        </p:txBody>
       </p:sp>
       <p:sp>
         <p:nvSpPr>
@@ -17392,6 +17684,10 @@
           </a:solidFill>
           <a:ln/>
         </p:spPr>
+        <p:txBody>
+          <a:bodyPr/>
+          <a:p/>
+        </p:txBody>
       </p:sp>
       <p:sp>
         <p:nvSpPr>
@@ -17506,6 +17802,10 @@
             <a:tailEnd type="none"/>
           </a:ln>
         </p:spPr>
+        <p:txBody>
+          <a:bodyPr/>
+          <a:p/>
+        </p:txBody>
       </p:sp>
       <p:sp>
         <p:nvSpPr>
@@ -17547,6 +17847,10 @@
           </a:solidFill>
           <a:ln/>
         </p:spPr>
+        <p:txBody>
+          <a:bodyPr/>
+          <a:p/>
+        </p:txBody>
       </p:sp>
       <p:sp>
         <p:nvSpPr>
@@ -19067,6 +19371,10 @@
             <a:prstDash val="solid"/>
           </a:ln>
         </p:spPr>
+        <p:txBody>
+          <a:bodyPr/>
+          <a:p/>
+        </p:txBody>
       </p:sp>
       <p:sp>
         <p:nvSpPr>
@@ -19192,6 +19500,10 @@
           </a:solidFill>
           <a:ln/>
         </p:spPr>
+        <p:txBody>
+          <a:bodyPr/>
+          <a:p/>
+        </p:txBody>
       </p:sp>
       <p:sp>
         <p:nvSpPr>
@@ -19306,6 +19618,10 @@
             <a:tailEnd type="none"/>
           </a:ln>
         </p:spPr>
+        <p:txBody>
+          <a:bodyPr/>
+          <a:p/>
+        </p:txBody>
       </p:sp>
     </p:spTree>
   </p:cSld>
@@ -19360,6 +19676,10 @@
             <a:tailEnd type="none"/>
           </a:ln>
         </p:spPr>
+        <p:txBody>
+          <a:bodyPr/>
+          <a:p/>
+        </p:txBody>
       </p:sp>
       <p:sp>
         <p:nvSpPr>
@@ -19401,6 +19721,10 @@
           </a:solidFill>
           <a:ln/>
         </p:spPr>
+        <p:txBody>
+          <a:bodyPr/>
+          <a:p/>
+        </p:txBody>
       </p:sp>
       <p:sp>
         <p:nvSpPr>
@@ -20936,6 +21260,10 @@
             <a:tailEnd type="none"/>
           </a:ln>
         </p:spPr>
+        <p:txBody>
+          <a:bodyPr/>
+          <a:p/>
+        </p:txBody>
       </p:sp>
     </p:spTree>
   </p:cSld>
@@ -20990,6 +21318,10 @@
             <a:tailEnd type="none"/>
           </a:ln>
         </p:spPr>
+        <p:txBody>
+          <a:bodyPr/>
+          <a:p/>
+        </p:txBody>
       </p:sp>
       <p:sp>
         <p:nvSpPr>
@@ -21031,6 +21363,10 @@
           </a:solidFill>
           <a:ln/>
         </p:spPr>
+        <p:txBody>
+          <a:bodyPr/>
+          <a:p/>
+        </p:txBody>
       </p:sp>
       <p:sp>
         <p:nvSpPr>
@@ -21230,6 +21566,10 @@
             <a:prstDash val="solid"/>
           </a:ln>
         </p:spPr>
+        <p:txBody>
+          <a:bodyPr/>
+          <a:p/>
+        </p:txBody>
       </p:sp>
       <p:sp>
         <p:nvSpPr>
@@ -21401,6 +21741,10 @@
             <a:prstDash val="solid"/>
           </a:ln>
         </p:spPr>
+        <p:txBody>
+          <a:bodyPr/>
+          <a:p/>
+        </p:txBody>
       </p:sp>
       <p:sp>
         <p:nvSpPr>
@@ -21515,6 +21859,10 @@
             <a:tailEnd type="none"/>
           </a:ln>
         </p:spPr>
+        <p:txBody>
+          <a:bodyPr/>
+          <a:p/>
+        </p:txBody>
       </p:sp>
     </p:spTree>
   </p:cSld>

</xml_diff>